<commit_message>
Integrate Japanese slide skill work and retain incomplete quality review records
</commit_message>
<xml_diff>
--- a/examples/repositories/agent-slides-showcase/deck.pptx
+++ b/examples/repositories/agent-slides-showcase/deck.pptx
@@ -7,7 +7,7 @@
   <p:sldIdLst>
     <p:sldId id="256" r:id="rId7"/>
   </p:sldIdLst>
-  <p:sldSz cx="12191695" cy="6858000" type="screen4x3"/>
+  <p:sldSz cx="12192000" cy="6858000" type="screen4x3"/>
   <p:notesSz cx="6858000" cy="9144000"/>
   <p:defaultTextStyle>
     <a:defPPr>
@@ -529,7 +529,15 @@
 
 <file path=ppt/slideLayouts/slideLayout1.xml><?xml version="1.0" encoding="utf-8"?>
 <p:sldLayout xmlns:a="http://schemas.openxmlformats.org/drawingml/2006/main" xmlns:r="http://schemas.openxmlformats.org/officeDocument/2006/relationships" xmlns:p="http://schemas.openxmlformats.org/presentationml/2006/main" type="title" preserve="1">
-  <p:cSld name="Title Slide">
+  <p:cSld name="Workshop Cover">
+    <p:bg>
+      <p:bgPr>
+        <a:solidFill>
+          <a:srgbClr val="102D45"/>
+        </a:solidFill>
+        <a:effectLst/>
+      </p:bgPr>
+    </p:bg>
     <p:spTree>
       <p:nvGrpSpPr>
         <p:cNvPr id="1" name=""/>
@@ -546,213 +554,196 @@
       </p:grpSpPr>
       <p:sp>
         <p:nvSpPr>
-          <p:cNvPr id="2" name="Title 1"/>
-          <p:cNvSpPr>
-            <a:spLocks noGrp="1"/>
-          </p:cNvSpPr>
-          <p:nvPr>
-            <p:ph type="ctrTitle"/>
-          </p:nvPr>
-        </p:nvSpPr>
-        <p:spPr>
-          <a:xfrm>
-            <a:off x="685800" y="2130425"/>
-            <a:ext cx="7772400" cy="1470025"/>
-          </a:xfrm>
-        </p:spPr>
-        <p:txBody>
-          <a:bodyPr/>
-          <a:lstStyle/>
-          <a:p>
-            <a:r>
-              <a:rPr lang="en-US" smtClean="0"/>
-              <a:t>Click to edit Master title style</a:t>
-            </a:r>
-            <a:endParaRPr lang="en-US"/>
-          </a:p>
-        </p:txBody>
-      </p:sp>
-      <p:sp>
-        <p:nvSpPr>
-          <p:cNvPr id="3" name="Subtitle 2"/>
-          <p:cNvSpPr>
-            <a:spLocks noGrp="1"/>
-          </p:cNvSpPr>
-          <p:nvPr>
-            <p:ph type="subTitle" idx="1"/>
-          </p:nvPr>
-        </p:nvSpPr>
-        <p:spPr>
-          <a:xfrm>
-            <a:off x="1371600" y="3886200"/>
-            <a:ext cx="6400800" cy="1752600"/>
-          </a:xfrm>
-        </p:spPr>
-        <p:txBody>
-          <a:bodyPr/>
+          <p:cNvPr id="4" name="Workshop Cover Band"/>
+          <p:cNvSpPr/>
+          <p:nvPr userDrawn="1"/>
+        </p:nvSpPr>
+        <p:spPr>
+          <a:xfrm>
+            <a:off x="0" y="6492240"/>
+            <a:ext cx="12192000" cy="365760"/>
+          </a:xfrm>
+          <a:prstGeom prst="rect">
+            <a:avLst/>
+          </a:prstGeom>
+          <a:solidFill>
+            <a:srgbClr val="FF6A13"/>
+          </a:solidFill>
+          <a:ln>
+            <a:noFill/>
+          </a:ln>
+        </p:spPr>
+      </p:sp>
+      <p:sp>
+        <p:nvSpPr>
+          <p:cNvPr id="5" name="Workshop Cover Rule"/>
+          <p:cNvSpPr/>
+          <p:nvPr userDrawn="1"/>
+        </p:nvSpPr>
+        <p:spPr>
+          <a:xfrm>
+            <a:off x="5547208" y="4087368"/>
+            <a:ext cx="1097280" cy="64008"/>
+          </a:xfrm>
+          <a:prstGeom prst="rect">
+            <a:avLst/>
+          </a:prstGeom>
+          <a:solidFill>
+            <a:srgbClr val="FF6A13"/>
+          </a:solidFill>
+          <a:ln>
+            <a:noFill/>
+          </a:ln>
+        </p:spPr>
+      </p:sp>
+      <p:sp>
+        <p:nvSpPr>
+          <p:cNvPr id="6" name="Workshop Cover Label"/>
+          <p:cNvSpPr txBox="1"/>
+          <p:nvPr userDrawn="1"/>
+        </p:nvSpPr>
+        <p:spPr>
+          <a:xfrm>
+            <a:off x="2026768" y="566928"/>
+            <a:ext cx="8138160" cy="310896"/>
+          </a:xfrm>
+          <a:prstGeom prst="rect">
+            <a:avLst/>
+          </a:prstGeom>
+          <a:noFill/>
+        </p:spPr>
+        <p:txBody>
+          <a:bodyPr vert="horz" wrap="square" lIns="91440" tIns="45720" rIns="91440" bIns="45720" rtlCol="0" anchor="t">
+            <a:noAutofit/>
+          </a:bodyPr>
+          <a:lstStyle/>
+          <a:p>
+            <a:pPr algn="ctr"/>
+            <a:r>
+              <a:rPr lang="en-US" dirty="0" sz="1200" b="0">
+                <a:solidFill>
+                  <a:srgbClr val="D9E7F1"/>
+                </a:solidFill>
+                <a:latin typeface="Manrope"/>
+                <a:ea typeface="Zen Kaku Gothic New"/>
+                <a:cs typeface="Manrope"/>
+              </a:rPr>
+              <a:t>A DAY TO MAKE / CONCEPT PROPOSAL</a:t>
+            </a:r>
+          </a:p>
+        </p:txBody>
+      </p:sp>
+      <p:sp>
+        <p:nvSpPr>
+          <p:cNvPr id="2" name="Workshop Cover Title"/>
+          <p:cNvSpPr>
+            <a:spLocks noGrp="1"/>
+          </p:cNvSpPr>
+          <p:nvPr>
+            <p:ph type="ctrTitle" hasCustomPrompt="1"/>
+          </p:nvPr>
+        </p:nvSpPr>
+        <p:spPr>
+          <a:xfrm>
+            <a:off x="822960" y="2011680"/>
+            <a:ext cx="10545775" cy="1920240"/>
+          </a:xfrm>
+        </p:spPr>
+        <p:txBody>
+          <a:bodyPr vert="horz" wrap="square" lIns="91440" tIns="45720" rIns="91440" bIns="45720" rtlCol="0" anchor="b">
+            <a:noAutofit/>
+          </a:bodyPr>
           <a:lstStyle>
             <a:lvl1pPr marL="0" indent="0" algn="ctr">
-              <a:buNone/>
-              <a:defRPr>
+              <a:lnSpc>
+                <a:spcPct val="100000"/>
+              </a:lnSpc>
+              <a:spcBef>
+                <a:spcPts val="0"/>
+              </a:spcBef>
+              <a:buNone/>
+              <a:defRPr sz="4800" b="1">
                 <a:solidFill>
-                  <a:schemeClr val="tx1">
-                    <a:tint val="75000"/>
-                  </a:schemeClr>
+                  <a:srgbClr val="FFFFFF"/>
                 </a:solidFill>
+                <a:latin typeface="Zen Kaku Gothic New"/>
+                <a:ea typeface="Zen Kaku Gothic New"/>
+                <a:cs typeface="Zen Kaku Gothic New"/>
               </a:defRPr>
             </a:lvl1pPr>
-            <a:lvl2pPr marL="457200" indent="0" algn="ctr">
-              <a:buNone/>
-              <a:defRPr>
+          </a:lstStyle>
+          <a:p>
+            <a:pPr>
+              <a:defRPr sz="4800" b="1">
                 <a:solidFill>
-                  <a:schemeClr val="tx1">
-                    <a:tint val="75000"/>
-                  </a:schemeClr>
+                  <a:srgbClr val="FFFFFF"/>
                 </a:solidFill>
+                <a:latin typeface="Zen Kaku Gothic New"/>
+                <a:ea typeface="Zen Kaku Gothic New"/>
+                <a:cs typeface="Zen Kaku Gothic New"/>
               </a:defRPr>
-            </a:lvl2pPr>
-            <a:lvl3pPr marL="914400" indent="0" algn="ctr">
-              <a:buNone/>
-              <a:defRPr>
+            </a:pPr>
+            <a:r>
+              <a:rPr lang="ja-JP" altLang="en-US"/>
+              <a:t>表紙の見出しを入力</a:t>
+            </a:r>
+          </a:p>
+        </p:txBody>
+      </p:sp>
+      <p:sp>
+        <p:nvSpPr>
+          <p:cNvPr id="3" name="Workshop Cover Subtitle"/>
+          <p:cNvSpPr>
+            <a:spLocks noGrp="1"/>
+          </p:cNvSpPr>
+          <p:nvPr>
+            <p:ph type="subTitle" idx="1" hasCustomPrompt="1"/>
+          </p:nvPr>
+        </p:nvSpPr>
+        <p:spPr>
+          <a:xfrm>
+            <a:off x="1524305" y="4343400"/>
+            <a:ext cx="9144000" cy="914400"/>
+          </a:xfrm>
+        </p:spPr>
+        <p:txBody>
+          <a:bodyPr vert="horz" wrap="square" lIns="91440" tIns="45720" rIns="91440" bIns="45720" rtlCol="0" anchor="t">
+            <a:normAutofit/>
+          </a:bodyPr>
+          <a:lstStyle>
+            <a:lvl1pPr marL="0" indent="0" algn="ctr">
+              <a:lnSpc>
+                <a:spcPct val="100000"/>
+              </a:lnSpc>
+              <a:spcBef>
+                <a:spcPts val="0"/>
+              </a:spcBef>
+              <a:buNone/>
+              <a:defRPr sz="2000" b="0">
                 <a:solidFill>
-                  <a:schemeClr val="tx1">
-                    <a:tint val="75000"/>
-                  </a:schemeClr>
+                  <a:srgbClr val="D9E7F1"/>
                 </a:solidFill>
+                <a:latin typeface="Zen Kaku Gothic New"/>
+                <a:ea typeface="Zen Kaku Gothic New"/>
+                <a:cs typeface="Zen Kaku Gothic New"/>
               </a:defRPr>
-            </a:lvl3pPr>
-            <a:lvl4pPr marL="1371600" indent="0" algn="ctr">
-              <a:buNone/>
-              <a:defRPr>
+            </a:lvl1pPr>
+          </a:lstStyle>
+          <a:p>
+            <a:pPr>
+              <a:defRPr sz="2000" b="0">
                 <a:solidFill>
-                  <a:schemeClr val="tx1">
-                    <a:tint val="75000"/>
-                  </a:schemeClr>
+                  <a:srgbClr val="D9E7F1"/>
                 </a:solidFill>
+                <a:latin typeface="Zen Kaku Gothic New"/>
+                <a:ea typeface="Zen Kaku Gothic New"/>
+                <a:cs typeface="Zen Kaku Gothic New"/>
               </a:defRPr>
-            </a:lvl4pPr>
-            <a:lvl5pPr marL="1828800" indent="0" algn="ctr">
-              <a:buNone/>
-              <a:defRPr>
-                <a:solidFill>
-                  <a:schemeClr val="tx1">
-                    <a:tint val="75000"/>
-                  </a:schemeClr>
-                </a:solidFill>
-              </a:defRPr>
-            </a:lvl5pPr>
-            <a:lvl6pPr marL="2286000" indent="0" algn="ctr">
-              <a:buNone/>
-              <a:defRPr>
-                <a:solidFill>
-                  <a:schemeClr val="tx1">
-                    <a:tint val="75000"/>
-                  </a:schemeClr>
-                </a:solidFill>
-              </a:defRPr>
-            </a:lvl6pPr>
-            <a:lvl7pPr marL="2743200" indent="0" algn="ctr">
-              <a:buNone/>
-              <a:defRPr>
-                <a:solidFill>
-                  <a:schemeClr val="tx1">
-                    <a:tint val="75000"/>
-                  </a:schemeClr>
-                </a:solidFill>
-              </a:defRPr>
-            </a:lvl7pPr>
-            <a:lvl8pPr marL="3200400" indent="0" algn="ctr">
-              <a:buNone/>
-              <a:defRPr>
-                <a:solidFill>
-                  <a:schemeClr val="tx1">
-                    <a:tint val="75000"/>
-                  </a:schemeClr>
-                </a:solidFill>
-              </a:defRPr>
-            </a:lvl8pPr>
-            <a:lvl9pPr marL="3657600" indent="0" algn="ctr">
-              <a:buNone/>
-              <a:defRPr>
-                <a:solidFill>
-                  <a:schemeClr val="tx1">
-                    <a:tint val="75000"/>
-                  </a:schemeClr>
-                </a:solidFill>
-              </a:defRPr>
-            </a:lvl9pPr>
-          </a:lstStyle>
-          <a:p>
-            <a:r>
-              <a:rPr lang="en-US" smtClean="0"/>
-              <a:t>Click to edit Master subtitle style</a:t>
-            </a:r>
-            <a:endParaRPr lang="en-US"/>
-          </a:p>
-        </p:txBody>
-      </p:sp>
-      <p:sp>
-        <p:nvSpPr>
-          <p:cNvPr id="4" name="Date Placeholder 3"/>
-          <p:cNvSpPr>
-            <a:spLocks noGrp="1"/>
-          </p:cNvSpPr>
-          <p:nvPr>
-            <p:ph type="dt" sz="half" idx="10"/>
-          </p:nvPr>
-        </p:nvSpPr>
-        <p:spPr/>
-        <p:txBody>
-          <a:bodyPr/>
-          <a:lstStyle/>
-          <a:p>
-            <a:fld id="{5BCAD085-E8A6-8845-BD4E-CB4CCA059FC4}" type="datetimeFigureOut">
-              <a:rPr lang="en-US" smtClean="0"/>
-              <a:t>1/27/13</a:t>
-            </a:fld>
-            <a:endParaRPr lang="en-US"/>
-          </a:p>
-        </p:txBody>
-      </p:sp>
-      <p:sp>
-        <p:nvSpPr>
-          <p:cNvPr id="5" name="Footer Placeholder 4"/>
-          <p:cNvSpPr>
-            <a:spLocks noGrp="1"/>
-          </p:cNvSpPr>
-          <p:nvPr>
-            <p:ph type="ftr" sz="quarter" idx="11"/>
-          </p:nvPr>
-        </p:nvSpPr>
-        <p:spPr/>
-        <p:txBody>
-          <a:bodyPr/>
-          <a:lstStyle/>
-          <a:p>
-            <a:endParaRPr lang="en-US"/>
-          </a:p>
-        </p:txBody>
-      </p:sp>
-      <p:sp>
-        <p:nvSpPr>
-          <p:cNvPr id="6" name="Slide Number Placeholder 5"/>
-          <p:cNvSpPr>
-            <a:spLocks noGrp="1"/>
-          </p:cNvSpPr>
-          <p:nvPr>
-            <p:ph type="sldNum" sz="quarter" idx="12"/>
-          </p:nvPr>
-        </p:nvSpPr>
-        <p:spPr/>
-        <p:txBody>
-          <a:bodyPr/>
-          <a:lstStyle/>
-          <a:p>
-            <a:fld id="{C1FF6DA9-008F-8B48-92A6-B652298478BF}" type="slidenum">
-              <a:rPr lang="en-US" smtClean="0"/>
-              <a:t>‹#›</a:t>
-            </a:fld>
-            <a:endParaRPr lang="en-US"/>
+            </a:pPr>
+            <a:r>
+              <a:rPr lang="ja-JP" altLang="en-US"/>
+              <a:t>補足の一文を入力</a:t>
+            </a:r>
           </a:p>
         </p:txBody>
       </p:sp>
@@ -968,8 +959,8 @@
         </p:nvSpPr>
         <p:spPr>
           <a:xfrm>
-            <a:off x="6629400" y="274638"/>
-            <a:ext cx="2057400" cy="5851525"/>
+            <a:off x="8839200" y="274638"/>
+            <a:ext cx="2743200" cy="5851525"/>
           </a:xfrm>
         </p:spPr>
         <p:txBody>
@@ -996,8 +987,8 @@
         </p:nvSpPr>
         <p:spPr>
           <a:xfrm>
-            <a:off x="457200" y="274638"/>
-            <a:ext cx="6019800" cy="5851525"/>
+            <a:off x="609600" y="274638"/>
+            <a:ext cx="8026400" cy="5851525"/>
           </a:xfrm>
         </p:spPr>
         <p:txBody>
@@ -1121,7 +1112,15 @@
 
 <file path=ppt/slideLayouts/slideLayout2.xml><?xml version="1.0" encoding="utf-8"?>
 <p:sldLayout xmlns:a="http://schemas.openxmlformats.org/drawingml/2006/main" xmlns:r="http://schemas.openxmlformats.org/officeDocument/2006/relationships" xmlns:p="http://schemas.openxmlformats.org/presentationml/2006/main" type="obj" preserve="1">
-  <p:cSld name="Title and Content">
+  <p:cSld name="Workshop Split">
+    <p:bg>
+      <p:bgPr>
+        <a:solidFill>
+          <a:srgbClr val="102D45"/>
+        </a:solidFill>
+        <a:effectLst/>
+      </p:bgPr>
+    </p:bg>
     <p:spTree>
       <p:nvGrpSpPr>
         <p:cNvPr id="1" name=""/>
@@ -1138,141 +1137,242 @@
       </p:grpSpPr>
       <p:sp>
         <p:nvSpPr>
-          <p:cNvPr id="2" name="Title 1"/>
-          <p:cNvSpPr>
-            <a:spLocks noGrp="1"/>
-          </p:cNvSpPr>
-          <p:nvPr>
-            <p:ph type="title"/>
-          </p:nvPr>
-        </p:nvSpPr>
-        <p:spPr/>
-        <p:txBody>
-          <a:bodyPr/>
-          <a:lstStyle/>
-          <a:p>
-            <a:r>
-              <a:rPr lang="en-US" smtClean="0"/>
-              <a:t>Click to edit Master title style</a:t>
-            </a:r>
-            <a:endParaRPr lang="en-US"/>
-          </a:p>
-        </p:txBody>
-      </p:sp>
-      <p:sp>
-        <p:nvSpPr>
-          <p:cNvPr id="3" name="Content Placeholder 2"/>
-          <p:cNvSpPr>
-            <a:spLocks noGrp="1"/>
-          </p:cNvSpPr>
-          <p:nvPr>
-            <p:ph idx="1"/>
-          </p:nvPr>
-        </p:nvSpPr>
-        <p:spPr/>
-        <p:txBody>
-          <a:bodyPr/>
-          <a:lstStyle/>
-          <a:p>
-            <a:pPr lvl="0"/>
-            <a:r>
-              <a:rPr lang="en-US" smtClean="0"/>
-              <a:t>Click to edit Master text styles</a:t>
-            </a:r>
-          </a:p>
-          <a:p>
-            <a:pPr lvl="1"/>
-            <a:r>
-              <a:rPr lang="en-US" smtClean="0"/>
-              <a:t>Second level</a:t>
-            </a:r>
-          </a:p>
-          <a:p>
-            <a:pPr lvl="2"/>
-            <a:r>
-              <a:rPr lang="en-US" smtClean="0"/>
-              <a:t>Third level</a:t>
-            </a:r>
-          </a:p>
-          <a:p>
-            <a:pPr lvl="3"/>
-            <a:r>
-              <a:rPr lang="en-US" smtClean="0"/>
-              <a:t>Fourth level</a:t>
-            </a:r>
-          </a:p>
-          <a:p>
-            <a:pPr lvl="4"/>
-            <a:r>
-              <a:rPr lang="en-US" smtClean="0"/>
-              <a:t>Fifth level</a:t>
-            </a:r>
-            <a:endParaRPr lang="en-US"/>
-          </a:p>
-        </p:txBody>
-      </p:sp>
-      <p:sp>
-        <p:nvSpPr>
-          <p:cNvPr id="4" name="Date Placeholder 3"/>
-          <p:cNvSpPr>
-            <a:spLocks noGrp="1"/>
-          </p:cNvSpPr>
-          <p:nvPr>
-            <p:ph type="dt" sz="half" idx="10"/>
-          </p:nvPr>
-        </p:nvSpPr>
-        <p:spPr/>
-        <p:txBody>
-          <a:bodyPr/>
-          <a:lstStyle/>
-          <a:p>
-            <a:fld id="{5BCAD085-E8A6-8845-BD4E-CB4CCA059FC4}" type="datetimeFigureOut">
-              <a:rPr lang="en-US" smtClean="0"/>
-              <a:t>1/27/13</a:t>
-            </a:fld>
-            <a:endParaRPr lang="en-US"/>
-          </a:p>
-        </p:txBody>
-      </p:sp>
-      <p:sp>
-        <p:nvSpPr>
-          <p:cNvPr id="5" name="Footer Placeholder 4"/>
-          <p:cNvSpPr>
-            <a:spLocks noGrp="1"/>
-          </p:cNvSpPr>
-          <p:nvPr>
-            <p:ph type="ftr" sz="quarter" idx="11"/>
-          </p:nvPr>
-        </p:nvSpPr>
-        <p:spPr/>
-        <p:txBody>
-          <a:bodyPr/>
-          <a:lstStyle/>
-          <a:p>
-            <a:endParaRPr lang="en-US"/>
-          </a:p>
-        </p:txBody>
-      </p:sp>
-      <p:sp>
-        <p:nvSpPr>
-          <p:cNvPr id="6" name="Slide Number Placeholder 5"/>
-          <p:cNvSpPr>
-            <a:spLocks noGrp="1"/>
-          </p:cNvSpPr>
-          <p:nvPr>
-            <p:ph type="sldNum" sz="quarter" idx="12"/>
-          </p:nvPr>
-        </p:nvSpPr>
-        <p:spPr/>
-        <p:txBody>
-          <a:bodyPr/>
-          <a:lstStyle/>
-          <a:p>
-            <a:fld id="{C1FF6DA9-008F-8B48-92A6-B652298478BF}" type="slidenum">
-              <a:rPr lang="en-US" smtClean="0"/>
-              <a:t>‹#›</a:t>
-            </a:fld>
-            <a:endParaRPr lang="en-US"/>
+          <p:cNvPr id="4" name="Workshop Side Panel"/>
+          <p:cNvSpPr/>
+          <p:nvPr userDrawn="1"/>
+        </p:nvSpPr>
+        <p:spPr>
+          <a:xfrm>
+            <a:off x="9162288" y="0"/>
+            <a:ext cx="3029712" cy="6858000"/>
+          </a:xfrm>
+          <a:prstGeom prst="rect">
+            <a:avLst/>
+          </a:prstGeom>
+          <a:solidFill>
+            <a:srgbClr val="FF6A13"/>
+          </a:solidFill>
+          <a:ln>
+            <a:noFill/>
+          </a:ln>
+        </p:spPr>
+      </p:sp>
+      <p:sp>
+        <p:nvSpPr>
+          <p:cNvPr id="5" name="Workshop Label"/>
+          <p:cNvSpPr txBox="1"/>
+          <p:nvPr userDrawn="1"/>
+        </p:nvSpPr>
+        <p:spPr>
+          <a:xfrm>
+            <a:off x="566928" y="301752"/>
+            <a:ext cx="8138160" cy="310896"/>
+          </a:xfrm>
+          <a:prstGeom prst="rect">
+            <a:avLst/>
+          </a:prstGeom>
+          <a:noFill/>
+        </p:spPr>
+        <p:txBody>
+          <a:bodyPr vert="horz" wrap="square" lIns="91440" tIns="45720" rIns="91440" bIns="45720" rtlCol="0" anchor="t">
+            <a:noAutofit/>
+          </a:bodyPr>
+          <a:lstStyle/>
+          <a:p>
+            <a:pPr algn="l"/>
+            <a:r>
+              <a:rPr lang="en-US" dirty="0" sz="1200" b="0">
+                <a:solidFill>
+                  <a:srgbClr val="D9E7F1"/>
+                </a:solidFill>
+                <a:latin typeface="Manrope"/>
+                <a:ea typeface="Zen Kaku Gothic New"/>
+                <a:cs typeface="Manrope"/>
+              </a:rPr>
+              <a:t>A DAY TO MAKE / CONCEPT PROPOSAL</a:t>
+            </a:r>
+          </a:p>
+        </p:txBody>
+      </p:sp>
+      <p:sp>
+        <p:nvSpPr>
+          <p:cNvPr id="2" name="Workshop Title"/>
+          <p:cNvSpPr>
+            <a:spLocks noGrp="1"/>
+          </p:cNvSpPr>
+          <p:nvPr>
+            <p:ph type="title" hasCustomPrompt="1"/>
+          </p:nvPr>
+        </p:nvSpPr>
+        <p:spPr>
+          <a:xfrm>
+            <a:off x="530352" y="822960"/>
+            <a:ext cx="8321040" cy="2084832"/>
+          </a:xfrm>
+        </p:spPr>
+        <p:txBody>
+          <a:bodyPr vert="horz" wrap="square" lIns="91440" tIns="45720" rIns="91440" bIns="45720" rtlCol="0" anchor="t">
+            <a:noAutofit/>
+          </a:bodyPr>
+          <a:lstStyle>
+            <a:lvl1pPr marL="0" indent="0" algn="l">
+              <a:lnSpc>
+                <a:spcPct val="100000"/>
+              </a:lnSpc>
+              <a:spcBef>
+                <a:spcPts val="0"/>
+              </a:spcBef>
+              <a:buNone/>
+              <a:defRPr sz="5200" b="1">
+                <a:solidFill>
+                  <a:srgbClr val="FFFFFF"/>
+                </a:solidFill>
+                <a:latin typeface="Zen Kaku Gothic New"/>
+                <a:ea typeface="Zen Kaku Gothic New"/>
+                <a:cs typeface="Zen Kaku Gothic New"/>
+              </a:defRPr>
+            </a:lvl1pPr>
+          </a:lstStyle>
+          <a:p>
+            <a:pPr>
+              <a:defRPr sz="5200" b="1">
+                <a:solidFill>
+                  <a:srgbClr val="FFFFFF"/>
+                </a:solidFill>
+                <a:latin typeface="Zen Kaku Gothic New"/>
+                <a:ea typeface="Zen Kaku Gothic New"/>
+                <a:cs typeface="Zen Kaku Gothic New"/>
+              </a:defRPr>
+            </a:pPr>
+            <a:r>
+              <a:rPr lang="ja-JP" altLang="en-US"/>
+              <a:t>見出しを入力</a:t>
+            </a:r>
+          </a:p>
+        </p:txBody>
+      </p:sp>
+      <p:sp>
+        <p:nvSpPr>
+          <p:cNvPr id="3" name="Workshop Body"/>
+          <p:cNvSpPr>
+            <a:spLocks noGrp="1"/>
+          </p:cNvSpPr>
+          <p:nvPr>
+            <p:ph idx="1" type="body" hasCustomPrompt="1"/>
+          </p:nvPr>
+        </p:nvSpPr>
+        <p:spPr>
+          <a:xfrm>
+            <a:off x="594360" y="3063240"/>
+            <a:ext cx="7973568" cy="868680"/>
+          </a:xfrm>
+        </p:spPr>
+        <p:txBody>
+          <a:bodyPr vert="horz" wrap="square" lIns="91440" tIns="45720" rIns="91440" bIns="45720" rtlCol="0" anchor="t">
+            <a:normAutofit/>
+          </a:bodyPr>
+          <a:lstStyle>
+            <a:lvl1pPr marL="0" indent="0" algn="l">
+              <a:lnSpc>
+                <a:spcPct val="100000"/>
+              </a:lnSpc>
+              <a:spcBef>
+                <a:spcPts val="0"/>
+              </a:spcBef>
+              <a:buNone/>
+              <a:defRPr sz="2300" b="0">
+                <a:solidFill>
+                  <a:srgbClr val="FFFFFF"/>
+                </a:solidFill>
+                <a:latin typeface="Zen Kaku Gothic New"/>
+                <a:ea typeface="Zen Kaku Gothic New"/>
+                <a:cs typeface="Zen Kaku Gothic New"/>
+              </a:defRPr>
+            </a:lvl1pPr>
+            <a:lvl2pPr marL="274320" indent="0" algn="l">
+              <a:lnSpc>
+                <a:spcPct val="100000"/>
+              </a:lnSpc>
+              <a:spcBef>
+                <a:spcPts val="0"/>
+              </a:spcBef>
+              <a:buNone/>
+              <a:defRPr sz="2300" b="0">
+                <a:solidFill>
+                  <a:srgbClr val="FFFFFF"/>
+                </a:solidFill>
+                <a:latin typeface="Zen Kaku Gothic New"/>
+                <a:ea typeface="Zen Kaku Gothic New"/>
+                <a:cs typeface="Zen Kaku Gothic New"/>
+              </a:defRPr>
+            </a:lvl2pPr>
+            <a:lvl3pPr marL="548640" indent="0" algn="l">
+              <a:lnSpc>
+                <a:spcPct val="100000"/>
+              </a:lnSpc>
+              <a:spcBef>
+                <a:spcPts val="0"/>
+              </a:spcBef>
+              <a:buNone/>
+              <a:defRPr sz="2300" b="0">
+                <a:solidFill>
+                  <a:srgbClr val="FFFFFF"/>
+                </a:solidFill>
+                <a:latin typeface="Zen Kaku Gothic New"/>
+                <a:ea typeface="Zen Kaku Gothic New"/>
+                <a:cs typeface="Zen Kaku Gothic New"/>
+              </a:defRPr>
+            </a:lvl3pPr>
+            <a:lvl4pPr marL="822960" indent="0" algn="l">
+              <a:lnSpc>
+                <a:spcPct val="100000"/>
+              </a:lnSpc>
+              <a:spcBef>
+                <a:spcPts val="0"/>
+              </a:spcBef>
+              <a:buNone/>
+              <a:defRPr sz="2300" b="0">
+                <a:solidFill>
+                  <a:srgbClr val="FFFFFF"/>
+                </a:solidFill>
+                <a:latin typeface="Zen Kaku Gothic New"/>
+                <a:ea typeface="Zen Kaku Gothic New"/>
+                <a:cs typeface="Zen Kaku Gothic New"/>
+              </a:defRPr>
+            </a:lvl4pPr>
+            <a:lvl5pPr marL="1097280" indent="0" algn="l">
+              <a:lnSpc>
+                <a:spcPct val="100000"/>
+              </a:lnSpc>
+              <a:spcBef>
+                <a:spcPts val="0"/>
+              </a:spcBef>
+              <a:buNone/>
+              <a:defRPr sz="2300" b="0">
+                <a:solidFill>
+                  <a:srgbClr val="FFFFFF"/>
+                </a:solidFill>
+                <a:latin typeface="Zen Kaku Gothic New"/>
+                <a:ea typeface="Zen Kaku Gothic New"/>
+                <a:cs typeface="Zen Kaku Gothic New"/>
+              </a:defRPr>
+            </a:lvl5pPr>
+          </a:lstStyle>
+          <a:p>
+            <a:pPr>
+              <a:defRPr sz="2300" b="0">
+                <a:solidFill>
+                  <a:srgbClr val="FFFFFF"/>
+                </a:solidFill>
+                <a:latin typeface="Zen Kaku Gothic New"/>
+                <a:ea typeface="Zen Kaku Gothic New"/>
+                <a:cs typeface="Zen Kaku Gothic New"/>
+              </a:defRPr>
+            </a:pPr>
+            <a:r>
+              <a:rPr lang="ja-JP" altLang="en-US"/>
+              <a:t>本文を入力</a:t>
+            </a:r>
           </a:p>
         </p:txBody>
       </p:sp>
@@ -1318,8 +1418,8 @@
         </p:nvSpPr>
         <p:spPr>
           <a:xfrm>
-            <a:off x="722313" y="4406900"/>
-            <a:ext cx="7772400" cy="1362075"/>
+            <a:off x="963084" y="4406900"/>
+            <a:ext cx="10363200" cy="1362075"/>
           </a:xfrm>
         </p:spPr>
         <p:txBody>
@@ -1350,8 +1450,8 @@
         </p:nvSpPr>
         <p:spPr>
           <a:xfrm>
-            <a:off x="722313" y="2906713"/>
-            <a:ext cx="7772400" cy="1500187"/>
+            <a:off x="963084" y="2906713"/>
+            <a:ext cx="10363200" cy="1500187"/>
           </a:xfrm>
         </p:spPr>
         <p:txBody>
@@ -1587,8 +1687,8 @@
         </p:nvSpPr>
         <p:spPr>
           <a:xfrm>
-            <a:off x="457200" y="1600200"/>
-            <a:ext cx="4038600" cy="4525963"/>
+            <a:off x="609600" y="1600200"/>
+            <a:ext cx="5384800" cy="4525963"/>
           </a:xfrm>
         </p:spPr>
         <p:txBody>
@@ -1672,8 +1772,8 @@
         </p:nvSpPr>
         <p:spPr>
           <a:xfrm>
-            <a:off x="4648200" y="1600200"/>
-            <a:ext cx="4038600" cy="4525963"/>
+            <a:off x="6197600" y="1600200"/>
+            <a:ext cx="5384800" cy="4525963"/>
           </a:xfrm>
         </p:spPr>
         <p:txBody>
@@ -1879,8 +1979,8 @@
         </p:nvSpPr>
         <p:spPr>
           <a:xfrm>
-            <a:off x="457200" y="1535113"/>
-            <a:ext cx="4040188" cy="639762"/>
+            <a:off x="609600" y="1535113"/>
+            <a:ext cx="5386917" cy="639762"/>
           </a:xfrm>
         </p:spPr>
         <p:txBody>
@@ -1944,8 +2044,8 @@
         </p:nvSpPr>
         <p:spPr>
           <a:xfrm>
-            <a:off x="457200" y="2174875"/>
-            <a:ext cx="4040188" cy="3951288"/>
+            <a:off x="609600" y="2174875"/>
+            <a:ext cx="5386917" cy="3951288"/>
           </a:xfrm>
         </p:spPr>
         <p:txBody>
@@ -2029,8 +2129,8 @@
         </p:nvSpPr>
         <p:spPr>
           <a:xfrm>
-            <a:off x="4645025" y="1535113"/>
-            <a:ext cx="4041775" cy="639762"/>
+            <a:off x="6193367" y="1535113"/>
+            <a:ext cx="5389033" cy="639762"/>
           </a:xfrm>
         </p:spPr>
         <p:txBody>
@@ -2094,8 +2194,8 @@
         </p:nvSpPr>
         <p:spPr>
           <a:xfrm>
-            <a:off x="4645025" y="2174875"/>
-            <a:ext cx="4041775" cy="3951288"/>
+            <a:off x="6193367" y="2174875"/>
+            <a:ext cx="5389033" cy="3951288"/>
           </a:xfrm>
         </p:spPr>
         <p:txBody>
@@ -2487,8 +2587,8 @@
         </p:nvSpPr>
         <p:spPr>
           <a:xfrm>
-            <a:off x="457200" y="273050"/>
-            <a:ext cx="3008313" cy="1162050"/>
+            <a:off x="609600" y="273050"/>
+            <a:ext cx="4011084" cy="1162050"/>
           </a:xfrm>
         </p:spPr>
         <p:txBody>
@@ -2519,8 +2619,8 @@
         </p:nvSpPr>
         <p:spPr>
           <a:xfrm>
-            <a:off x="3575050" y="273050"/>
-            <a:ext cx="5111750" cy="5853113"/>
+            <a:off x="4766733" y="273050"/>
+            <a:ext cx="6815667" cy="5853113"/>
           </a:xfrm>
         </p:spPr>
         <p:txBody>
@@ -2604,8 +2704,8 @@
         </p:nvSpPr>
         <p:spPr>
           <a:xfrm>
-            <a:off x="457200" y="1435100"/>
-            <a:ext cx="3008313" cy="4691063"/>
+            <a:off x="609600" y="1435100"/>
+            <a:ext cx="4011084" cy="4691063"/>
           </a:xfrm>
         </p:spPr>
         <p:txBody>
@@ -2764,8 +2864,8 @@
         </p:nvSpPr>
         <p:spPr>
           <a:xfrm>
-            <a:off x="1792288" y="4800600"/>
-            <a:ext cx="5486400" cy="566738"/>
+            <a:off x="2389717" y="4800600"/>
+            <a:ext cx="7315200" cy="566738"/>
           </a:xfrm>
         </p:spPr>
         <p:txBody>
@@ -2796,8 +2896,8 @@
         </p:nvSpPr>
         <p:spPr>
           <a:xfrm>
-            <a:off x="1792288" y="612775"/>
-            <a:ext cx="5486400" cy="4114800"/>
+            <a:off x="2389717" y="612775"/>
+            <a:ext cx="7315200" cy="4114800"/>
           </a:xfrm>
         </p:spPr>
         <p:txBody>
@@ -2857,8 +2957,8 @@
         </p:nvSpPr>
         <p:spPr>
           <a:xfrm>
-            <a:off x="1792288" y="5367338"/>
-            <a:ext cx="5486400" cy="804862"/>
+            <a:off x="2389717" y="5367338"/>
+            <a:ext cx="7315200" cy="804862"/>
           </a:xfrm>
         </p:spPr>
         <p:txBody>
@@ -3022,8 +3122,8 @@
         </p:nvSpPr>
         <p:spPr>
           <a:xfrm>
-            <a:off x="457200" y="274638"/>
-            <a:ext cx="8229600" cy="1143000"/>
+            <a:off x="609600" y="274638"/>
+            <a:ext cx="10972800" cy="1143000"/>
           </a:xfrm>
           <a:prstGeom prst="rect">
             <a:avLst/>
@@ -3055,8 +3155,8 @@
         </p:nvSpPr>
         <p:spPr>
           <a:xfrm>
-            <a:off x="457200" y="1600200"/>
-            <a:ext cx="8229600" cy="4525963"/>
+            <a:off x="609600" y="1600200"/>
+            <a:ext cx="10972800" cy="4525963"/>
           </a:xfrm>
           <a:prstGeom prst="rect">
             <a:avLst/>
@@ -3117,8 +3217,8 @@
         </p:nvSpPr>
         <p:spPr>
           <a:xfrm>
-            <a:off x="457200" y="6356350"/>
-            <a:ext cx="2133600" cy="365125"/>
+            <a:off x="609600" y="6356350"/>
+            <a:ext cx="2844800" cy="365125"/>
           </a:xfrm>
           <a:prstGeom prst="rect">
             <a:avLst/>
@@ -3158,8 +3258,8 @@
         </p:nvSpPr>
         <p:spPr>
           <a:xfrm>
-            <a:off x="3124200" y="6356350"/>
-            <a:ext cx="2895600" cy="365125"/>
+            <a:off x="4165600" y="6356350"/>
+            <a:ext cx="3860800" cy="365125"/>
           </a:xfrm>
           <a:prstGeom prst="rect">
             <a:avLst/>
@@ -3195,8 +3295,8 @@
         </p:nvSpPr>
         <p:spPr>
           <a:xfrm>
-            <a:off x="6553200" y="6356350"/>
-            <a:ext cx="2133600" cy="365125"/>
+            <a:off x="8737600" y="6356350"/>
+            <a:ext cx="2844800" cy="365125"/>
           </a:xfrm>
           <a:prstGeom prst="rect">
             <a:avLst/>
@@ -3510,207 +3610,53 @@
       <p:grpSpPr/>
       <p:sp>
         <p:nvSpPr>
-          <p:cNvPr id="2" name="Rectangle 1"/>
-          <p:cNvSpPr/>
-          <p:nvPr/>
-        </p:nvSpPr>
-        <p:spPr>
-          <a:xfrm>
-            <a:off x="0" y="0"/>
-            <a:ext cx="12191695" cy="6858000"/>
-          </a:xfrm>
-          <a:prstGeom prst="rect">
-            <a:avLst/>
-          </a:prstGeom>
-          <a:solidFill>
-            <a:srgbClr val="102D45"/>
-          </a:solidFill>
-          <a:ln>
-            <a:noFill/>
-          </a:ln>
-        </p:spPr>
-        <p:style>
-          <a:lnRef idx="1">
-            <a:schemeClr val="accent1"/>
-          </a:lnRef>
-          <a:fillRef idx="3">
-            <a:schemeClr val="accent1"/>
-          </a:fillRef>
-          <a:effectRef idx="2">
-            <a:schemeClr val="accent1"/>
-          </a:effectRef>
-          <a:fontRef idx="minor">
-            <a:schemeClr val="lt1"/>
-          </a:fontRef>
-        </p:style>
-        <p:txBody>
-          <a:bodyPr rtlCol="0" anchor="ctr"/>
-          <a:lstStyle/>
-          <a:p>
-            <a:pPr algn="ctr"/>
-          </a:p>
-        </p:txBody>
-      </p:sp>
-      <p:sp>
-        <p:nvSpPr>
-          <p:cNvPr id="3" name="Rectangle 2"/>
-          <p:cNvSpPr/>
-          <p:nvPr/>
-        </p:nvSpPr>
-        <p:spPr>
-          <a:xfrm>
-            <a:off x="9162288" y="0"/>
-            <a:ext cx="3029407" cy="6858000"/>
-          </a:xfrm>
-          <a:prstGeom prst="rect">
-            <a:avLst/>
-          </a:prstGeom>
-          <a:solidFill>
-            <a:srgbClr val="FF6A13"/>
-          </a:solidFill>
-          <a:ln>
-            <a:noFill/>
-          </a:ln>
-        </p:spPr>
-        <p:style>
-          <a:lnRef idx="1">
-            <a:schemeClr val="accent1"/>
-          </a:lnRef>
-          <a:fillRef idx="3">
-            <a:schemeClr val="accent1"/>
-          </a:fillRef>
-          <a:effectRef idx="2">
-            <a:schemeClr val="accent1"/>
-          </a:effectRef>
-          <a:fontRef idx="minor">
-            <a:schemeClr val="lt1"/>
-          </a:fontRef>
-        </p:style>
-        <p:txBody>
-          <a:bodyPr rtlCol="0" anchor="ctr"/>
-          <a:lstStyle/>
-          <a:p>
-            <a:pPr algn="ctr"/>
-          </a:p>
-        </p:txBody>
-      </p:sp>
-      <p:sp>
-        <p:nvSpPr>
-          <p:cNvPr id="4" name="TextBox 3"/>
-          <p:cNvSpPr txBox="1"/>
-          <p:nvPr/>
-        </p:nvSpPr>
-        <p:spPr>
-          <a:xfrm>
-            <a:off x="566928" y="301752"/>
-            <a:ext cx="8138160" cy="310896"/>
-          </a:xfrm>
-          <a:prstGeom prst="rect">
-            <a:avLst/>
-          </a:prstGeom>
-          <a:noFill/>
-        </p:spPr>
-        <p:txBody>
-          <a:bodyPr wrap="square">
+          <p:cNvPr id="2" name="Title 1"/>
+          <p:cNvSpPr>
+            <a:spLocks noGrp="1"/>
+          </p:cNvSpPr>
+          <p:nvPr>
+            <p:ph type="title"/>
+          </p:nvPr>
+        </p:nvSpPr>
+        <p:spPr/>
+        <p:txBody>
+          <a:bodyPr/>
+          <a:lstStyle/>
+          <a:p>
+            <a:r>
+              <a:t>土曜日を、</a:t>
+            </a:r>
+          </a:p>
+          <a:p>
+            <a:r>
+              <a:t>街の作業場に。</a:t>
+            </a:r>
+          </a:p>
+        </p:txBody>
+      </p:sp>
+      <p:sp>
+        <p:nvSpPr>
+          <p:cNvPr id="3" name="Text Placeholder 2"/>
+          <p:cNvSpPr>
+            <a:spLocks noGrp="1"/>
+          </p:cNvSpPr>
+          <p:nvPr>
+            <p:ph type="body" idx="1"/>
+          </p:nvPr>
+        </p:nvSpPr>
+        <p:spPr/>
+        <p:txBody>
+          <a:bodyPr>
             <a:normAutofit/>
           </a:bodyPr>
           <a:lstStyle/>
           <a:p>
             <a:r>
-              <a:rPr sz="1200" b="0">
-                <a:solidFill>
-                  <a:srgbClr val="D9E7F1"/>
-                </a:solidFill>
-                <a:latin typeface="Manrope"/>
-              </a:rPr>
-              <a:t>A DAY TO MAKE / CONCEPT PROPOSAL</a:t>
-            </a:r>
-          </a:p>
-        </p:txBody>
-      </p:sp>
-      <p:sp>
-        <p:nvSpPr>
-          <p:cNvPr id="5" name="TextBox 4"/>
-          <p:cNvSpPr txBox="1"/>
-          <p:nvPr/>
-        </p:nvSpPr>
-        <p:spPr>
-          <a:xfrm>
-            <a:off x="530352" y="822960"/>
-            <a:ext cx="8321040" cy="2084831"/>
-          </a:xfrm>
-          <a:prstGeom prst="rect">
-            <a:avLst/>
-          </a:prstGeom>
-          <a:noFill/>
-        </p:spPr>
-        <p:txBody>
-          <a:bodyPr wrap="square">
-            <a:normAutofit/>
-          </a:bodyPr>
-          <a:lstStyle/>
-          <a:p>
-            <a:r>
-              <a:rPr sz="5200" b="1">
-                <a:solidFill>
-                  <a:srgbClr val="FFFFFF"/>
-                </a:solidFill>
-                <a:latin typeface="Zen Kaku Gothic New"/>
-              </a:rPr>
-              <a:t>土曜日を、</a:t>
-            </a:r>
-            <a:br/>
-            <a:r>
-              <a:rPr sz="5200" b="1">
-                <a:solidFill>
-                  <a:srgbClr val="FFFFFF"/>
-                </a:solidFill>
-                <a:latin typeface="Zen Kaku Gothic New"/>
-              </a:rPr>
-              <a:t>街の作業場に。</a:t>
-            </a:r>
-          </a:p>
-        </p:txBody>
-      </p:sp>
-      <p:sp>
-        <p:nvSpPr>
-          <p:cNvPr id="6" name="TextBox 5"/>
-          <p:cNvSpPr txBox="1"/>
-          <p:nvPr/>
-        </p:nvSpPr>
-        <p:spPr>
-          <a:xfrm>
-            <a:off x="594360" y="3063240"/>
-            <a:ext cx="7973568" cy="868680"/>
-          </a:xfrm>
-          <a:prstGeom prst="rect">
-            <a:avLst/>
-          </a:prstGeom>
-          <a:noFill/>
-        </p:spPr>
-        <p:txBody>
-          <a:bodyPr wrap="square">
-            <a:normAutofit/>
-          </a:bodyPr>
-          <a:lstStyle/>
-          <a:p>
-            <a:r>
-              <a:rPr sz="2300" b="0">
-                <a:solidFill>
-                  <a:srgbClr val="FFFFFF"/>
-                </a:solidFill>
-                <a:latin typeface="Zen Kaku Gothic New"/>
-              </a:rPr>
               <a:t>つくる人も、見る人も。</a:t>
             </a:r>
-            <a:br/>
-            <a:r>
-              <a:rPr sz="2300" b="0">
-                <a:solidFill>
-                  <a:srgbClr val="FFFFFF"/>
-                </a:solidFill>
-                <a:latin typeface="Zen Kaku Gothic New"/>
-              </a:rPr>
+          </a:p>
+          <a:p>
+            <a:r>
               <a:t>一日だけ、同じ作業台に集まる。</a:t>
             </a:r>
           </a:p>
@@ -3718,7 +3664,7 @@
       </p:sp>
       <p:sp>
         <p:nvSpPr>
-          <p:cNvPr id="7" name="TextBox 6"/>
+          <p:cNvPr id="4" name="TextBox 3"/>
           <p:cNvSpPr txBox="1"/>
           <p:nvPr/>
         </p:nvSpPr>
@@ -3752,14 +3698,14 @@
       </p:sp>
       <p:cxnSp>
         <p:nvCxnSpPr>
-          <p:cNvPr id="8" name="Connector 7"/>
+          <p:cNvPr id="5" name="Connector 4"/>
           <p:cNvCxnSpPr/>
           <p:nvPr/>
         </p:nvCxnSpPr>
         <p:spPr>
           <a:xfrm>
-            <a:off x="1024128" y="4846320"/>
-            <a:ext cx="6675120" cy="0"/>
+            <a:off x="1060704" y="4846320"/>
+            <a:ext cx="5989320" cy="0"/>
           </a:xfrm>
           <a:prstGeom prst="line">
             <a:avLst/>
@@ -3787,7 +3733,7 @@
       </p:cxnSp>
       <p:sp>
         <p:nvSpPr>
-          <p:cNvPr id="9" name="Oval 8"/>
+          <p:cNvPr id="6" name="Oval 5"/>
           <p:cNvSpPr/>
           <p:nvPr/>
         </p:nvSpPr>
@@ -3830,7 +3776,7 @@
       </p:sp>
       <p:sp>
         <p:nvSpPr>
-          <p:cNvPr id="10" name="TextBox 9"/>
+          <p:cNvPr id="7" name="TextBox 6"/>
           <p:cNvSpPr txBox="1"/>
           <p:nvPr/>
         </p:nvSpPr>
@@ -3864,7 +3810,7 @@
       </p:sp>
       <p:sp>
         <p:nvSpPr>
-          <p:cNvPr id="11" name="TextBox 10"/>
+          <p:cNvPr id="8" name="TextBox 7"/>
           <p:cNvSpPr txBox="1"/>
           <p:nvPr/>
         </p:nvSpPr>
@@ -3898,7 +3844,7 @@
       </p:sp>
       <p:sp>
         <p:nvSpPr>
-          <p:cNvPr id="12" name="TextBox 11"/>
+          <p:cNvPr id="9" name="TextBox 8"/>
           <p:cNvSpPr txBox="1"/>
           <p:nvPr/>
         </p:nvSpPr>
@@ -3932,7 +3878,7 @@
       </p:sp>
       <p:sp>
         <p:nvSpPr>
-          <p:cNvPr id="13" name="Oval 12"/>
+          <p:cNvPr id="10" name="Oval 9"/>
           <p:cNvSpPr/>
           <p:nvPr/>
         </p:nvSpPr>
@@ -3975,7 +3921,7 @@
       </p:sp>
       <p:sp>
         <p:nvSpPr>
-          <p:cNvPr id="14" name="TextBox 13"/>
+          <p:cNvPr id="11" name="TextBox 10"/>
           <p:cNvSpPr txBox="1"/>
           <p:nvPr/>
         </p:nvSpPr>
@@ -4009,7 +3955,7 @@
       </p:sp>
       <p:sp>
         <p:nvSpPr>
-          <p:cNvPr id="15" name="TextBox 14"/>
+          <p:cNvPr id="12" name="TextBox 11"/>
           <p:cNvSpPr txBox="1"/>
           <p:nvPr/>
         </p:nvSpPr>
@@ -4043,7 +3989,7 @@
       </p:sp>
       <p:sp>
         <p:nvSpPr>
-          <p:cNvPr id="16" name="TextBox 15"/>
+          <p:cNvPr id="13" name="TextBox 12"/>
           <p:cNvSpPr txBox="1"/>
           <p:nvPr/>
         </p:nvSpPr>
@@ -4077,7 +4023,7 @@
       </p:sp>
       <p:sp>
         <p:nvSpPr>
-          <p:cNvPr id="17" name="Oval 16"/>
+          <p:cNvPr id="14" name="Oval 13"/>
           <p:cNvSpPr/>
           <p:nvPr/>
         </p:nvSpPr>
@@ -4120,7 +4066,7 @@
       </p:sp>
       <p:sp>
         <p:nvSpPr>
-          <p:cNvPr id="18" name="TextBox 17"/>
+          <p:cNvPr id="15" name="TextBox 14"/>
           <p:cNvSpPr txBox="1"/>
           <p:nvPr/>
         </p:nvSpPr>
@@ -4154,7 +4100,7 @@
       </p:sp>
       <p:sp>
         <p:nvSpPr>
-          <p:cNvPr id="19" name="TextBox 18"/>
+          <p:cNvPr id="16" name="TextBox 15"/>
           <p:cNvSpPr txBox="1"/>
           <p:nvPr/>
         </p:nvSpPr>
@@ -4188,7 +4134,7 @@
       </p:sp>
       <p:sp>
         <p:nvSpPr>
-          <p:cNvPr id="20" name="TextBox 19"/>
+          <p:cNvPr id="17" name="TextBox 16"/>
           <p:cNvSpPr txBox="1"/>
           <p:nvPr/>
         </p:nvSpPr>
@@ -4222,13 +4168,13 @@
       </p:sp>
       <p:sp>
         <p:nvSpPr>
-          <p:cNvPr id="21" name="TextBox 20"/>
+          <p:cNvPr id="18" name="TextBox 17"/>
           <p:cNvSpPr txBox="1"/>
           <p:nvPr/>
         </p:nvSpPr>
         <p:spPr>
           <a:xfrm>
-            <a:off x="621792" y="6510528"/>
+            <a:off x="621792" y="6428232"/>
             <a:ext cx="8183879" cy="256032"/>
           </a:xfrm>
           <a:prstGeom prst="rect">
@@ -4256,7 +4202,7 @@
       </p:sp>
       <p:sp>
         <p:nvSpPr>
-          <p:cNvPr id="22" name="TextBox 21"/>
+          <p:cNvPr id="19" name="TextBox 18"/>
           <p:cNvSpPr txBox="1"/>
           <p:nvPr/>
         </p:nvSpPr>
@@ -4300,7 +4246,7 @@
       </p:sp>
       <p:sp>
         <p:nvSpPr>
-          <p:cNvPr id="23" name="TextBox 22"/>
+          <p:cNvPr id="20" name="TextBox 19"/>
           <p:cNvSpPr txBox="1"/>
           <p:nvPr/>
         </p:nvSpPr>
@@ -4334,7 +4280,7 @@
       </p:sp>
       <p:sp>
         <p:nvSpPr>
-          <p:cNvPr id="24" name="TextBox 23"/>
+          <p:cNvPr id="21" name="TextBox 20"/>
           <p:cNvSpPr txBox="1"/>
           <p:nvPr/>
         </p:nvSpPr>
@@ -4378,7 +4324,7 @@
       </p:sp>
       <p:cxnSp>
         <p:nvCxnSpPr>
-          <p:cNvPr id="25" name="Connector 24"/>
+          <p:cNvPr id="22" name="Connector 21"/>
           <p:cNvCxnSpPr/>
           <p:nvPr/>
         </p:nvCxnSpPr>
@@ -4413,7 +4359,7 @@
       </p:cxnSp>
       <p:cxnSp>
         <p:nvCxnSpPr>
-          <p:cNvPr id="26" name="Connector 25"/>
+          <p:cNvPr id="23" name="Connector 22"/>
           <p:cNvCxnSpPr/>
           <p:nvPr/>
         </p:nvCxnSpPr>
@@ -4448,7 +4394,7 @@
       </p:cxnSp>
       <p:cxnSp>
         <p:nvCxnSpPr>
-          <p:cNvPr id="27" name="Connector 26"/>
+          <p:cNvPr id="24" name="Connector 23"/>
           <p:cNvCxnSpPr/>
           <p:nvPr/>
         </p:nvCxnSpPr>
@@ -4483,7 +4429,7 @@
       </p:cxnSp>
       <p:sp>
         <p:nvSpPr>
-          <p:cNvPr id="28" name="Oval 27"/>
+          <p:cNvPr id="25" name="Oval 24"/>
           <p:cNvSpPr/>
           <p:nvPr/>
         </p:nvSpPr>
@@ -4526,7 +4472,7 @@
       </p:sp>
       <p:sp>
         <p:nvSpPr>
-          <p:cNvPr id="29" name="Oval 28"/>
+          <p:cNvPr id="26" name="Oval 25"/>
           <p:cNvSpPr/>
           <p:nvPr/>
         </p:nvSpPr>
@@ -4569,7 +4515,7 @@
       </p:sp>
       <p:sp>
         <p:nvSpPr>
-          <p:cNvPr id="30" name="Oval 29"/>
+          <p:cNvPr id="27" name="Oval 26"/>
           <p:cNvSpPr/>
           <p:nvPr/>
         </p:nvSpPr>
@@ -4612,7 +4558,7 @@
       </p:sp>
       <p:sp>
         <p:nvSpPr>
-          <p:cNvPr id="31" name="Oval 30"/>
+          <p:cNvPr id="28" name="Oval 27"/>
           <p:cNvSpPr/>
           <p:nvPr/>
         </p:nvSpPr>
@@ -4655,7 +4601,7 @@
       </p:sp>
       <p:sp>
         <p:nvSpPr>
-          <p:cNvPr id="32" name="TextBox 31"/>
+          <p:cNvPr id="29" name="TextBox 28"/>
           <p:cNvSpPr txBox="1"/>
           <p:nvPr/>
         </p:nvSpPr>
@@ -4689,7 +4635,7 @@
       </p:sp>
       <p:sp>
         <p:nvSpPr>
-          <p:cNvPr id="33" name="TextBox 32"/>
+          <p:cNvPr id="30" name="TextBox 29"/>
           <p:cNvSpPr txBox="1"/>
           <p:nvPr/>
         </p:nvSpPr>
@@ -4723,7 +4669,7 @@
       </p:sp>
       <p:sp>
         <p:nvSpPr>
-          <p:cNvPr id="34" name="TextBox 33"/>
+          <p:cNvPr id="31" name="TextBox 30"/>
           <p:cNvSpPr txBox="1"/>
           <p:nvPr/>
         </p:nvSpPr>
@@ -4757,7 +4703,7 @@
       </p:sp>
       <p:sp>
         <p:nvSpPr>
-          <p:cNvPr id="35" name="TextBox 34"/>
+          <p:cNvPr id="32" name="TextBox 31"/>
           <p:cNvSpPr txBox="1"/>
           <p:nvPr/>
         </p:nvSpPr>
@@ -4791,7 +4737,7 @@
       </p:sp>
       <p:sp>
         <p:nvSpPr>
-          <p:cNvPr id="36" name="TextBox 35"/>
+          <p:cNvPr id="33" name="TextBox 32"/>
           <p:cNvSpPr txBox="1"/>
           <p:nvPr/>
         </p:nvSpPr>
@@ -4832,14 +4778,14 @@
 </file>
 
 <file path=ppt/theme/theme1.xml><?xml version="1.0" encoding="utf-8"?>
-<a:theme xmlns:a="http://schemas.openxmlformats.org/drawingml/2006/main" name="Office Theme">
+<a:theme xmlns:a="http://schemas.openxmlformats.org/drawingml/2006/main" name="Workshop Theme">
   <a:themeElements>
-    <a:clrScheme name="Office">
+    <a:clrScheme name="Workshop Palette">
       <a:dk1>
-        <a:sysClr val="windowText" lastClr="000000"/>
+        <a:srgbClr val="102D45"/>
       </a:dk1>
       <a:lt1>
-        <a:sysClr val="window" lastClr="FFFFFF"/>
+        <a:srgbClr val="FFFFFF"/>
       </a:lt1>
       <a:dk2>
         <a:srgbClr val="1F497D"/>
@@ -4848,7 +4794,7 @@
         <a:srgbClr val="EEECE1"/>
       </a:lt2>
       <a:accent1>
-        <a:srgbClr val="4F81BD"/>
+        <a:srgbClr val="FF6A13"/>
       </a:accent1>
       <a:accent2>
         <a:srgbClr val="C0504D"/>
@@ -4872,12 +4818,12 @@
         <a:srgbClr val="800080"/>
       </a:folHlink>
     </a:clrScheme>
-    <a:fontScheme name="Office">
+    <a:fontScheme name="Workshop Type">
       <a:majorFont>
-        <a:latin typeface="Calibri"/>
-        <a:ea typeface=""/>
+        <a:latin typeface="Zen Kaku Gothic New"/>
+        <a:ea typeface="Zen Kaku Gothic New"/>
         <a:cs typeface=""/>
-        <a:font script="Jpan" typeface="ＭＳ Ｐゴシック"/>
+        <a:font script="Jpan" typeface="Zen Kaku Gothic New"/>
         <a:font script="Hang" typeface="맑은 고딕"/>
         <a:font script="Hans" typeface="宋体"/>
         <a:font script="Hant" typeface="新細明體"/>
@@ -4909,10 +4855,10 @@
         <a:font script="Geor" typeface="Sylfaen"/>
       </a:majorFont>
       <a:minorFont>
-        <a:latin typeface="Calibri"/>
-        <a:ea typeface=""/>
+        <a:latin typeface="Zen Kaku Gothic New"/>
+        <a:ea typeface="Zen Kaku Gothic New"/>
         <a:cs typeface=""/>
-        <a:font script="Jpan" typeface="ＭＳ Ｐゴシック"/>
+        <a:font script="Jpan" typeface="Zen Kaku Gothic New"/>
         <a:font script="Hang" typeface="맑은 고딕"/>
         <a:font script="Hans" typeface="宋体"/>
         <a:font script="Hant" typeface="新細明體"/>

</xml_diff>